<commit_message>
Add architecture diagram, speaker notes, and Redis-vs-PI comparison
- docs/architecture.svg + .png rendered into the README
- Deck: speaker notes on every slide + new 'Redis vs querying PI directly' slide
- README: 'Why Redis in front of AVEVA PI' comparison section

Co-Authored-By: Claude Opus 4.8 <noreply@anthropic.com>
</commit_message>
<xml_diff>
--- a/demo/AVEVA-PI-Redis-Demo.pptx
+++ b/demo/AVEVA-PI-Redis-Demo.pptx
@@ -13,9 +13,10 @@
     <p:sldId id="261" r:id="rId7"/>
     <p:sldId id="262" r:id="rId8"/>
     <p:sldId id="263" r:id="rId9"/>
+    <p:sldId id="264" r:id="rId10"/>
   </p:sldIdLst>
   <p:notesMasterIdLst>
-    <p:notesMasterId r:id="rId10"/>
+    <p:notesMasterId r:id="rId11"/>
   </p:notesMasterIdLst>
   <p:sldSz cx="12192000" cy="6858000"/>
   <p:notesSz cx="6858000" cy="12192000"/>
@@ -509,7 +510,7 @@
           <a:p>
             <a:r>
               <a:rPr lang="en-US" dirty="0"/>
-              <a:t/>
+              <a:t>Welcome and thanks for the time. Today I'll show a working proof of concept that streams live operational data out of AVEVA PI and into Redis. The goal is simple: give your modern applications sub-millisecond access to sensor data without hammering the historian. Everything I'll show runs end-to-end on a laptop against a mock PI server, and all the code plus these slides are on GitHub at the link on the bottom-left.</a:t>
             </a:r>
             <a:endParaRPr lang="en-US" dirty="0"/>
           </a:p>
@@ -597,7 +598,7 @@
           <a:p>
             <a:r>
               <a:rPr lang="en-US" dirty="0"/>
-              <a:t/>
+              <a:t>The data your teams need already lives in PI — millions of tags going back years. The problem is getting it out fast enough for the applications that want it. Querying the historian directly through the Web API is fine for engineering tools, but it wasn't designed to serve thousands of concurrent app requests at low latency. So we need a bridge that moves PI data into a fast store continuously and reliably. The three cards on the right are the outcomes I'll demonstrate: sub-millisecond reads, one batched request per cycle, and zero data loss across restarts.</a:t>
             </a:r>
             <a:endParaRPr lang="en-US" dirty="0"/>
           </a:p>
@@ -685,7 +686,7 @@
           <a:p>
             <a:r>
               <a:rPr lang="en-US" dirty="0"/>
-              <a:t/>
+              <a:t>Here's the shape of it. A small Python service calls the PI Web API and reads recorded — that is, archived — values for all the tags in a single batched streamset request. It then writes each sample into Redis three ways: full history goes into RedisTimeSeries, the current value into a snapshot hash, and every new sample is published on a pub/sub channel. Consumers pick whatever fits: a charting tool reads the time-series, a status dashboard reads the snapshot hash, and an alerting service just subscribes to the live feed. The checkpoint key is what makes restarts safe — I'll come back to that in the demo.</a:t>
             </a:r>
             <a:endParaRPr lang="en-US" dirty="0"/>
           </a:p>
@@ -773,7 +774,7 @@
           <a:p>
             <a:r>
               <a:rPr lang="en-US" dirty="0"/>
-              <a:t/>
+              <a:t>I want to stress this is production-shaped, not a throwaway script. Four things matter. One: it backfills recorded values, so if a poll is slow or the app pauses, we still capture every archived sample in between. Two: it batches all tags into one request per cycle — that keeps load off PI and scales to many tags. Three: checkpoints. Each tag's last-seen timestamp is stored in Redis, so a restart resumes exactly where it left off, with no duplicates. Four: it's observable out of the box — a health endpoint and Prometheus metrics you can wire straight into your monitoring.</a:t>
             </a:r>
             <a:endParaRPr lang="en-US" dirty="0"/>
           </a:p>
@@ -861,7 +862,7 @@
           <a:p>
             <a:r>
               <a:rPr lang="en-US" dirty="0"/>
-              <a:t/>
+              <a:t>Now let me actually run it. First command brings up the whole stack — Redis, a mock PI Web API, and the integration service — in one shot. Then I'll query Redis directly to show history landing, and read the snapshot hash for the latest value. Third, I'll hit the health endpoint and show the Prometheus metrics ticking up. And the important one — step four — I'll kill the service, wait a few seconds to create an outage, then start it again and show in the logs that it resumes from the checkpoint and backfills the gap with no data lost and no duplicates. If you prefer a visual, RedisInsight at localhost:8001 shows the time-series as a live chart.</a:t>
             </a:r>
             <a:endParaRPr lang="en-US" dirty="0"/>
           </a:p>
@@ -949,7 +950,7 @@
           <a:p>
             <a:r>
               <a:rPr lang="en-US" dirty="0"/>
-              <a:t/>
+              <a:t>Why Redis specifically? Four reasons. It has native time-series — retention, downsampling, and cross-tag queries by label are built in, so we're not bolting a schema onto a plain key-value store. It's in-memory, so reads are sub-millisecond, which is exactly what dashboards, alerting and ML feature lookups need. It does real-time fan-out natively with pub/sub and streams. And it's multi-model — the same system does caching, time-series, messaging, and search, so you enrich sensor data with JSON context or run vector search without adding more infrastructure.</a:t>
             </a:r>
             <a:endParaRPr lang="en-US" dirty="0"/>
           </a:p>
@@ -1037,7 +1038,7 @@
           <a:p>
             <a:r>
               <a:rPr lang="en-US" dirty="0"/>
-              <a:t/>
+              <a:t>This is the slide to be honest and precise on, because it builds trust. Redis does not replace AVEVA PI. PI stays your system of record and your long-term compressed historian — that's what it's excellent at. What Redis adds is a fast serving layer in front of it. Walk down the rows: reads go from per-call REST latency to sub-millisecond; you go from a handful of clients that tax the historian to thousands served from replicas; delivery becomes push instead of poll; you get multiple data models, not just time-series; and critically, your apps hit Redis instead of PI, which protects your OT systems and your PI licensing. The bar at the bottom is the key message — say it out loud: PI is the source of truth, Redis is the speed layer.</a:t>
             </a:r>
             <a:endParaRPr lang="en-US" dirty="0"/>
           </a:p>
@@ -1125,7 +1126,7 @@
           <a:p>
             <a:r>
               <a:rPr lang="en-US" dirty="0"/>
-              <a:t/>
+              <a:t>Everything on the left is real and running today — that's what you just saw in the demo. The right column is the short path to production, and none of it is exotic: Kerberos authentication against your real PI server, TLS and ACLs to lock down Redis, sharding tags across workers if the tag count is large, downsampling rules for long-term rollups, wiring the metrics into your alerting stack, and packaging it for your deployment platform. This is a matter of days-to-weeks, not a rebuild.</a:t>
             </a:r>
             <a:endParaRPr lang="en-US" dirty="0"/>
           </a:p>
@@ -1149,6 +1150,94 @@
             <a:fld id="{F7021451-1387-4CA6-816F-3879F97B5CBC}" type="slidenum">
               <a:rPr lang="en-US"/>
               <a:t>8</a:t>
+            </a:fld>
+            <a:endParaRPr lang="en-US"/>
+          </a:p>
+        </p:txBody>
+      </p:sp>
+    </p:spTree>
+    <p:extLst>
+      <p:ext uri="{BB962C8B-B14F-4D97-AF65-F5344CB8AC3E}">
+        <p14:creationId xmlns:p14="http://schemas.microsoft.com/office/powerpoint/2010/main" val="1024086991"/>
+      </p:ext>
+    </p:extLst>
+  </p:cSld>
+  <p:clrMapOvr>
+    <a:masterClrMapping/>
+  </p:clrMapOvr>
+</p:notes>
+</file>
+
+<file path=ppt/notesSlides/notesSlide9.xml><?xml version="1.0" encoding="utf-8"?>
+<p:notes xmlns:a="http://schemas.openxmlformats.org/drawingml/2006/main" xmlns:r="http://schemas.openxmlformats.org/officeDocument/2006/relationships" xmlns:p="http://schemas.openxmlformats.org/presentationml/2006/main">
+  <p:cSld>
+    <p:spTree>
+      <p:nvGrpSpPr>
+        <p:cNvPr id="1" name=""/>
+        <p:cNvGrpSpPr/>
+        <p:nvPr/>
+      </p:nvGrpSpPr>
+      <p:grpSpPr>
+        <a:xfrm>
+          <a:off x="0" y="0"/>
+          <a:ext cx="0" cy="0"/>
+          <a:chOff x="0" y="0"/>
+          <a:chExt cx="0" cy="0"/>
+        </a:xfrm>
+      </p:grpSpPr>
+      <p:sp>
+        <p:nvSpPr>
+          <p:cNvPr id="2" name="Slide Image Placeholder 1"/>
+          <p:cNvSpPr>
+            <a:spLocks noGrp="1" noRot="1" noChangeAspect="1"/>
+          </p:cNvSpPr>
+          <p:nvPr>
+            <p:ph type="sldImg"/>
+          </p:nvPr>
+        </p:nvSpPr>
+        <p:spPr/>
+      </p:sp>
+      <p:sp>
+        <p:nvSpPr>
+          <p:cNvPr id="3" name="Notes Placeholder 2"/>
+          <p:cNvSpPr>
+            <a:spLocks noGrp="1"/>
+          </p:cNvSpPr>
+          <p:nvPr>
+            <p:ph type="body" idx="1"/>
+          </p:nvPr>
+        </p:nvSpPr>
+        <p:spPr/>
+        <p:txBody>
+          <a:bodyPr/>
+          <a:lstStyle/>
+          <a:p>
+            <a:r>
+              <a:rPr lang="en-US" dirty="0"/>
+              <a:t>That's the proof of concept. To recap: PI stays your system of record, and Redis gives your applications a sub-millisecond, real-time serving layer on top of it — with backfill and gap recovery so you never lose a sample. The code and these slides are on GitHub. The natural next step is to point this at a slice of your real PI tags in a short follow-up session and measure it on your data. Happy to set that up. Questions?</a:t>
+            </a:r>
+            <a:endParaRPr lang="en-US" dirty="0"/>
+          </a:p>
+        </p:txBody>
+      </p:sp>
+      <p:sp>
+        <p:nvSpPr>
+          <p:cNvPr id="4" name="Slide Number Placeholder 3"/>
+          <p:cNvSpPr>
+            <a:spLocks noGrp="1"/>
+          </p:cNvSpPr>
+          <p:nvPr>
+            <p:ph type="sldNum" sz="quarter" idx="10"/>
+          </p:nvPr>
+        </p:nvSpPr>
+        <p:spPr/>
+        <p:txBody>
+          <a:bodyPr/>
+          <a:lstStyle/>
+          <a:p>
+            <a:fld id="{F7021451-1387-4CA6-816F-3879F97B5CBC}" type="slidenum">
+              <a:rPr lang="en-US"/>
+              <a:t>9</a:t>
             </a:fld>
             <a:endParaRPr lang="en-US"/>
           </a:p>
@@ -1941,7 +2030,7 @@
         <p:spPr>
           <a:xfrm>
             <a:off x="640080" y="548640"/>
-            <a:ext cx="5486400" cy="274320"/>
+            <a:ext cx="7315200" cy="274320"/>
           </a:xfrm>
           <a:prstGeom prst="rect">
             <a:avLst/>
@@ -2786,7 +2875,7 @@
         <p:spPr>
           <a:xfrm>
             <a:off x="640080" y="502920"/>
-            <a:ext cx="5486400" cy="274320"/>
+            <a:ext cx="7315200" cy="274320"/>
           </a:xfrm>
           <a:prstGeom prst="rect">
             <a:avLst/>
@@ -3989,7 +4078,7 @@
         <p:spPr>
           <a:xfrm>
             <a:off x="640080" y="502920"/>
-            <a:ext cx="5486400" cy="274320"/>
+            <a:ext cx="7315200" cy="274320"/>
           </a:xfrm>
           <a:prstGeom prst="rect">
             <a:avLst/>
@@ -4873,7 +4962,7 @@
         <p:spPr>
           <a:xfrm>
             <a:off x="640080" y="548640"/>
-            <a:ext cx="5486400" cy="274320"/>
+            <a:ext cx="7315200" cy="274320"/>
           </a:xfrm>
           <a:prstGeom prst="rect">
             <a:avLst/>
@@ -5785,7 +5874,7 @@
         <p:spPr>
           <a:xfrm>
             <a:off x="640080" y="502920"/>
-            <a:ext cx="5486400" cy="274320"/>
+            <a:ext cx="7315200" cy="274320"/>
           </a:xfrm>
           <a:prstGeom prst="rect">
             <a:avLst/>
@@ -6520,8 +6609,1281 @@
         </p:nvSpPr>
         <p:spPr>
           <a:xfrm>
+            <a:off x="640080" y="457200"/>
+            <a:ext cx="7315200" cy="274320"/>
+          </a:xfrm>
+          <a:prstGeom prst="rect">
+            <a:avLst/>
+          </a:prstGeom>
+          <a:noFill/>
+          <a:ln/>
+        </p:spPr>
+        <p:txBody>
+          <a:bodyPr wrap="square" lIns="0" tIns="0" rIns="0" bIns="0" rtlCol="0" anchor="ctr"/>
+          <a:lstStyle/>
+          <a:p>
+            <a:pPr indent="0" marL="0">
+              <a:buNone/>
+            </a:pPr>
+            <a:r>
+              <a:rPr lang="en-US" sz="1200" b="1" spc="300" kern="0" dirty="0">
+                <a:solidFill>
+                  <a:srgbClr val="FF4438"/>
+                </a:solidFill>
+                <a:latin typeface="Calibri" pitchFamily="34" charset="0"/>
+                <a:ea typeface="Calibri" pitchFamily="34" charset="-122"/>
+                <a:cs typeface="Calibri" pitchFamily="34" charset="-120"/>
+              </a:rPr>
+              <a:t>REDIS VS. QUERYING PI DIRECTLY</a:t>
+            </a:r>
+            <a:endParaRPr lang="en-US" sz="1200" dirty="0"/>
+          </a:p>
+        </p:txBody>
+      </p:sp>
+      <p:sp>
+        <p:nvSpPr>
+          <p:cNvPr id="3" name="Text 1"/>
+          <p:cNvSpPr/>
+          <p:nvPr/>
+        </p:nvSpPr>
+        <p:spPr>
+          <a:xfrm>
+            <a:off x="640080" y="777240"/>
+            <a:ext cx="10515600" cy="548640"/>
+          </a:xfrm>
+          <a:prstGeom prst="rect">
+            <a:avLst/>
+          </a:prstGeom>
+          <a:noFill/>
+          <a:ln/>
+        </p:spPr>
+        <p:txBody>
+          <a:bodyPr wrap="square" lIns="0" tIns="0" rIns="0" bIns="0" rtlCol="0" anchor="ctr"/>
+          <a:lstStyle/>
+          <a:p>
+            <a:pPr indent="0" marL="0">
+              <a:buNone/>
+            </a:pPr>
+            <a:r>
+              <a:rPr lang="en-US" sz="3000" b="1" dirty="0">
+                <a:solidFill>
+                  <a:srgbClr val="163341"/>
+                </a:solidFill>
+                <a:latin typeface="Cambria" pitchFamily="34" charset="0"/>
+                <a:ea typeface="Cambria" pitchFamily="34" charset="-122"/>
+                <a:cs typeface="Cambria" pitchFamily="34" charset="-120"/>
+              </a:rPr>
+              <a:t>Why put Redis in front of the historian</a:t>
+            </a:r>
+            <a:endParaRPr lang="en-US" sz="3000" dirty="0"/>
+          </a:p>
+        </p:txBody>
+      </p:sp>
+      <p:sp>
+        <p:nvSpPr>
+          <p:cNvPr id="4" name="Shape 2"/>
+          <p:cNvSpPr/>
+          <p:nvPr/>
+        </p:nvSpPr>
+        <p:spPr>
+          <a:xfrm>
+            <a:off x="3977640" y="1600200"/>
+            <a:ext cx="3703320" cy="502920"/>
+          </a:xfrm>
+          <a:prstGeom prst="roundRect">
+            <a:avLst>
+              <a:gd name="adj" fmla="val 10909"/>
+            </a:avLst>
+          </a:prstGeom>
+          <a:solidFill>
+            <a:srgbClr val="163341"/>
+          </a:solidFill>
+          <a:ln/>
+        </p:spPr>
+      </p:sp>
+      <p:sp>
+        <p:nvSpPr>
+          <p:cNvPr id="5" name="Shape 3"/>
+          <p:cNvSpPr/>
+          <p:nvPr/>
+        </p:nvSpPr>
+        <p:spPr>
+          <a:xfrm>
+            <a:off x="7772400" y="1600200"/>
+            <a:ext cx="3776472" cy="502920"/>
+          </a:xfrm>
+          <a:prstGeom prst="roundRect">
+            <a:avLst>
+              <a:gd name="adj" fmla="val 10909"/>
+            </a:avLst>
+          </a:prstGeom>
+          <a:solidFill>
+            <a:srgbClr val="FF4438"/>
+          </a:solidFill>
+          <a:ln/>
+        </p:spPr>
+      </p:sp>
+      <p:sp>
+        <p:nvSpPr>
+          <p:cNvPr id="6" name="Text 4"/>
+          <p:cNvSpPr/>
+          <p:nvPr/>
+        </p:nvSpPr>
+        <p:spPr>
+          <a:xfrm>
+            <a:off x="4114800" y="1600200"/>
+            <a:ext cx="3429000" cy="502920"/>
+          </a:xfrm>
+          <a:prstGeom prst="rect">
+            <a:avLst/>
+          </a:prstGeom>
+          <a:noFill/>
+          <a:ln/>
+        </p:spPr>
+        <p:txBody>
+          <a:bodyPr wrap="square" lIns="0" tIns="0" rIns="0" bIns="0" rtlCol="0" anchor="ctr"/>
+          <a:lstStyle/>
+          <a:p>
+            <a:pPr indent="0" marL="0">
+              <a:buNone/>
+            </a:pPr>
+            <a:r>
+              <a:rPr lang="en-US" sz="1350" b="1" dirty="0">
+                <a:solidFill>
+                  <a:srgbClr val="FFFFFF"/>
+                </a:solidFill>
+                <a:latin typeface="Calibri" pitchFamily="34" charset="0"/>
+                <a:ea typeface="Calibri" pitchFamily="34" charset="-122"/>
+                <a:cs typeface="Calibri" pitchFamily="34" charset="-120"/>
+              </a:rPr>
+              <a:t>Querying PI Web API directly</a:t>
+            </a:r>
+            <a:endParaRPr lang="en-US" sz="1350" dirty="0"/>
+          </a:p>
+        </p:txBody>
+      </p:sp>
+      <p:sp>
+        <p:nvSpPr>
+          <p:cNvPr id="7" name="Text 5"/>
+          <p:cNvSpPr/>
+          <p:nvPr/>
+        </p:nvSpPr>
+        <p:spPr>
+          <a:xfrm>
+            <a:off x="7909560" y="1600200"/>
+            <a:ext cx="3502152" cy="502920"/>
+          </a:xfrm>
+          <a:prstGeom prst="rect">
+            <a:avLst/>
+          </a:prstGeom>
+          <a:noFill/>
+          <a:ln/>
+        </p:spPr>
+        <p:txBody>
+          <a:bodyPr wrap="square" lIns="0" tIns="0" rIns="0" bIns="0" rtlCol="0" anchor="ctr"/>
+          <a:lstStyle/>
+          <a:p>
+            <a:pPr indent="0" marL="0">
+              <a:buNone/>
+            </a:pPr>
+            <a:r>
+              <a:rPr lang="en-US" sz="1350" b="1" dirty="0">
+                <a:solidFill>
+                  <a:srgbClr val="FFFFFF"/>
+                </a:solidFill>
+                <a:latin typeface="Calibri" pitchFamily="34" charset="0"/>
+                <a:ea typeface="Calibri" pitchFamily="34" charset="-122"/>
+                <a:cs typeface="Calibri" pitchFamily="34" charset="-120"/>
+              </a:rPr>
+              <a:t>Serving via Redis</a:t>
+            </a:r>
+            <a:endParaRPr lang="en-US" sz="1350" dirty="0"/>
+          </a:p>
+        </p:txBody>
+      </p:sp>
+      <p:sp>
+        <p:nvSpPr>
+          <p:cNvPr id="8" name="Shape 6"/>
+          <p:cNvSpPr/>
+          <p:nvPr/>
+        </p:nvSpPr>
+        <p:spPr>
+          <a:xfrm>
+            <a:off x="640080" y="2194560"/>
+            <a:ext cx="10908792" cy="566928"/>
+          </a:xfrm>
+          <a:prstGeom prst="rect">
+            <a:avLst/>
+          </a:prstGeom>
+          <a:solidFill>
+            <a:srgbClr val="EEF2F4"/>
+          </a:solidFill>
+          <a:ln/>
+        </p:spPr>
+      </p:sp>
+      <p:sp>
+        <p:nvSpPr>
+          <p:cNvPr id="9" name="Shape 7"/>
+          <p:cNvSpPr/>
+          <p:nvPr/>
+        </p:nvSpPr>
+        <p:spPr>
+          <a:xfrm>
+            <a:off x="7772400" y="2194560"/>
+            <a:ext cx="3776472" cy="566928"/>
+          </a:xfrm>
+          <a:prstGeom prst="rect">
+            <a:avLst/>
+          </a:prstGeom>
+          <a:solidFill>
+            <a:srgbClr val="FFF1F0"/>
+          </a:solidFill>
+          <a:ln/>
+        </p:spPr>
+      </p:sp>
+      <p:sp>
+        <p:nvSpPr>
+          <p:cNvPr id="10" name="Text 8"/>
+          <p:cNvSpPr/>
+          <p:nvPr/>
+        </p:nvSpPr>
+        <p:spPr>
+          <a:xfrm>
+            <a:off x="731520" y="2194560"/>
+            <a:ext cx="3063240" cy="566928"/>
+          </a:xfrm>
+          <a:prstGeom prst="rect">
+            <a:avLst/>
+          </a:prstGeom>
+          <a:noFill/>
+          <a:ln/>
+        </p:spPr>
+        <p:txBody>
+          <a:bodyPr wrap="square" lIns="0" tIns="0" rIns="0" bIns="0" rtlCol="0" anchor="ctr"/>
+          <a:lstStyle/>
+          <a:p>
+            <a:pPr indent="0" marL="0">
+              <a:buNone/>
+            </a:pPr>
+            <a:r>
+              <a:rPr lang="en-US" sz="1300" b="1" dirty="0">
+                <a:solidFill>
+                  <a:srgbClr val="163341"/>
+                </a:solidFill>
+                <a:latin typeface="Calibri" pitchFamily="34" charset="0"/>
+                <a:ea typeface="Calibri" pitchFamily="34" charset="-122"/>
+                <a:cs typeface="Calibri" pitchFamily="34" charset="-120"/>
+              </a:rPr>
+              <a:t>Read latency</a:t>
+            </a:r>
+            <a:endParaRPr lang="en-US" sz="1300" dirty="0"/>
+          </a:p>
+        </p:txBody>
+      </p:sp>
+      <p:sp>
+        <p:nvSpPr>
+          <p:cNvPr id="11" name="Text 9"/>
+          <p:cNvSpPr/>
+          <p:nvPr/>
+        </p:nvSpPr>
+        <p:spPr>
+          <a:xfrm>
+            <a:off x="4114800" y="2194560"/>
+            <a:ext cx="3429000" cy="566928"/>
+          </a:xfrm>
+          <a:prstGeom prst="rect">
+            <a:avLst/>
+          </a:prstGeom>
+          <a:noFill/>
+          <a:ln/>
+        </p:spPr>
+        <p:txBody>
+          <a:bodyPr wrap="square" lIns="0" tIns="0" rIns="0" bIns="0" rtlCol="0" anchor="ctr"/>
+          <a:lstStyle/>
+          <a:p>
+            <a:pPr indent="0" marL="0">
+              <a:buNone/>
+            </a:pPr>
+            <a:r>
+              <a:rPr lang="en-US" sz="1250" dirty="0">
+                <a:solidFill>
+                  <a:srgbClr val="5C6B73"/>
+                </a:solidFill>
+                <a:latin typeface="Calibri" pitchFamily="34" charset="0"/>
+                <a:ea typeface="Calibri" pitchFamily="34" charset="-122"/>
+                <a:cs typeface="Calibri" pitchFamily="34" charset="-120"/>
+              </a:rPr>
+              <a:t>Per-request REST call</a:t>
+            </a:r>
+            <a:endParaRPr lang="en-US" sz="1250" dirty="0"/>
+          </a:p>
+        </p:txBody>
+      </p:sp>
+      <p:sp>
+        <p:nvSpPr>
+          <p:cNvPr id="12" name="Text 10"/>
+          <p:cNvSpPr/>
+          <p:nvPr/>
+        </p:nvSpPr>
+        <p:spPr>
+          <a:xfrm>
+            <a:off x="7909560" y="2194560"/>
+            <a:ext cx="3502152" cy="566928"/>
+          </a:xfrm>
+          <a:prstGeom prst="rect">
+            <a:avLst/>
+          </a:prstGeom>
+          <a:noFill/>
+          <a:ln/>
+        </p:spPr>
+        <p:txBody>
+          <a:bodyPr wrap="square" lIns="0" tIns="0" rIns="0" bIns="0" rtlCol="0" anchor="ctr"/>
+          <a:lstStyle/>
+          <a:p>
+            <a:pPr indent="0" marL="0">
+              <a:buNone/>
+            </a:pPr>
+            <a:r>
+              <a:rPr lang="en-US" sz="1250" b="1" dirty="0">
+                <a:solidFill>
+                  <a:srgbClr val="9E241B"/>
+                </a:solidFill>
+                <a:latin typeface="Calibri" pitchFamily="34" charset="0"/>
+                <a:ea typeface="Calibri" pitchFamily="34" charset="-122"/>
+                <a:cs typeface="Calibri" pitchFamily="34" charset="-120"/>
+              </a:rPr>
+              <a:t>Sub-millisecond, in-memory</a:t>
+            </a:r>
+            <a:endParaRPr lang="en-US" sz="1250" dirty="0"/>
+          </a:p>
+        </p:txBody>
+      </p:sp>
+      <p:sp>
+        <p:nvSpPr>
+          <p:cNvPr id="13" name="Shape 11"/>
+          <p:cNvSpPr/>
+          <p:nvPr/>
+        </p:nvSpPr>
+        <p:spPr>
+          <a:xfrm>
+            <a:off x="7772400" y="2761488"/>
+            <a:ext cx="3776472" cy="566928"/>
+          </a:xfrm>
+          <a:prstGeom prst="rect">
+            <a:avLst/>
+          </a:prstGeom>
+          <a:solidFill>
+            <a:srgbClr val="FFF1F0"/>
+          </a:solidFill>
+          <a:ln/>
+        </p:spPr>
+      </p:sp>
+      <p:sp>
+        <p:nvSpPr>
+          <p:cNvPr id="14" name="Text 12"/>
+          <p:cNvSpPr/>
+          <p:nvPr/>
+        </p:nvSpPr>
+        <p:spPr>
+          <a:xfrm>
+            <a:off x="731520" y="2761488"/>
+            <a:ext cx="3063240" cy="566928"/>
+          </a:xfrm>
+          <a:prstGeom prst="rect">
+            <a:avLst/>
+          </a:prstGeom>
+          <a:noFill/>
+          <a:ln/>
+        </p:spPr>
+        <p:txBody>
+          <a:bodyPr wrap="square" lIns="0" tIns="0" rIns="0" bIns="0" rtlCol="0" anchor="ctr"/>
+          <a:lstStyle/>
+          <a:p>
+            <a:pPr indent="0" marL="0">
+              <a:buNone/>
+            </a:pPr>
+            <a:r>
+              <a:rPr lang="en-US" sz="1300" b="1" dirty="0">
+                <a:solidFill>
+                  <a:srgbClr val="163341"/>
+                </a:solidFill>
+                <a:latin typeface="Calibri" pitchFamily="34" charset="0"/>
+                <a:ea typeface="Calibri" pitchFamily="34" charset="-122"/>
+                <a:cs typeface="Calibri" pitchFamily="34" charset="-120"/>
+              </a:rPr>
+              <a:t>Concurrent app clients</a:t>
+            </a:r>
+            <a:endParaRPr lang="en-US" sz="1300" dirty="0"/>
+          </a:p>
+        </p:txBody>
+      </p:sp>
+      <p:sp>
+        <p:nvSpPr>
+          <p:cNvPr id="15" name="Text 13"/>
+          <p:cNvSpPr/>
+          <p:nvPr/>
+        </p:nvSpPr>
+        <p:spPr>
+          <a:xfrm>
+            <a:off x="4114800" y="2761488"/>
+            <a:ext cx="3429000" cy="566928"/>
+          </a:xfrm>
+          <a:prstGeom prst="rect">
+            <a:avLst/>
+          </a:prstGeom>
+          <a:noFill/>
+          <a:ln/>
+        </p:spPr>
+        <p:txBody>
+          <a:bodyPr wrap="square" lIns="0" tIns="0" rIns="0" bIns="0" rtlCol="0" anchor="ctr"/>
+          <a:lstStyle/>
+          <a:p>
+            <a:pPr indent="0" marL="0">
+              <a:buNone/>
+            </a:pPr>
+            <a:r>
+              <a:rPr lang="en-US" sz="1250" dirty="0">
+                <a:solidFill>
+                  <a:srgbClr val="5C6B73"/>
+                </a:solidFill>
+                <a:latin typeface="Calibri" pitchFamily="34" charset="0"/>
+                <a:ea typeface="Calibri" pitchFamily="34" charset="-122"/>
+                <a:cs typeface="Calibri" pitchFamily="34" charset="-120"/>
+              </a:rPr>
+              <a:t>Limited — load lands on PI</a:t>
+            </a:r>
+            <a:endParaRPr lang="en-US" sz="1250" dirty="0"/>
+          </a:p>
+        </p:txBody>
+      </p:sp>
+      <p:sp>
+        <p:nvSpPr>
+          <p:cNvPr id="16" name="Text 14"/>
+          <p:cNvSpPr/>
+          <p:nvPr/>
+        </p:nvSpPr>
+        <p:spPr>
+          <a:xfrm>
+            <a:off x="7909560" y="2761488"/>
+            <a:ext cx="3502152" cy="566928"/>
+          </a:xfrm>
+          <a:prstGeom prst="rect">
+            <a:avLst/>
+          </a:prstGeom>
+          <a:noFill/>
+          <a:ln/>
+        </p:spPr>
+        <p:txBody>
+          <a:bodyPr wrap="square" lIns="0" tIns="0" rIns="0" bIns="0" rtlCol="0" anchor="ctr"/>
+          <a:lstStyle/>
+          <a:p>
+            <a:pPr indent="0" marL="0">
+              <a:buNone/>
+            </a:pPr>
+            <a:r>
+              <a:rPr lang="en-US" sz="1250" b="1" dirty="0">
+                <a:solidFill>
+                  <a:srgbClr val="9E241B"/>
+                </a:solidFill>
+                <a:latin typeface="Calibri" pitchFamily="34" charset="0"/>
+                <a:ea typeface="Calibri" pitchFamily="34" charset="-122"/>
+                <a:cs typeface="Calibri" pitchFamily="34" charset="-120"/>
+              </a:rPr>
+              <a:t>Thousands, scaled via replicas</a:t>
+            </a:r>
+            <a:endParaRPr lang="en-US" sz="1250" dirty="0"/>
+          </a:p>
+        </p:txBody>
+      </p:sp>
+      <p:sp>
+        <p:nvSpPr>
+          <p:cNvPr id="17" name="Shape 15"/>
+          <p:cNvSpPr/>
+          <p:nvPr/>
+        </p:nvSpPr>
+        <p:spPr>
+          <a:xfrm>
+            <a:off x="640080" y="3328416"/>
+            <a:ext cx="10908792" cy="566928"/>
+          </a:xfrm>
+          <a:prstGeom prst="rect">
+            <a:avLst/>
+          </a:prstGeom>
+          <a:solidFill>
+            <a:srgbClr val="EEF2F4"/>
+          </a:solidFill>
+          <a:ln/>
+        </p:spPr>
+      </p:sp>
+      <p:sp>
+        <p:nvSpPr>
+          <p:cNvPr id="18" name="Shape 16"/>
+          <p:cNvSpPr/>
+          <p:nvPr/>
+        </p:nvSpPr>
+        <p:spPr>
+          <a:xfrm>
+            <a:off x="7772400" y="3328416"/>
+            <a:ext cx="3776472" cy="566928"/>
+          </a:xfrm>
+          <a:prstGeom prst="rect">
+            <a:avLst/>
+          </a:prstGeom>
+          <a:solidFill>
+            <a:srgbClr val="FFF1F0"/>
+          </a:solidFill>
+          <a:ln/>
+        </p:spPr>
+      </p:sp>
+      <p:sp>
+        <p:nvSpPr>
+          <p:cNvPr id="19" name="Text 17"/>
+          <p:cNvSpPr/>
+          <p:nvPr/>
+        </p:nvSpPr>
+        <p:spPr>
+          <a:xfrm>
+            <a:off x="731520" y="3328416"/>
+            <a:ext cx="3063240" cy="566928"/>
+          </a:xfrm>
+          <a:prstGeom prst="rect">
+            <a:avLst/>
+          </a:prstGeom>
+          <a:noFill/>
+          <a:ln/>
+        </p:spPr>
+        <p:txBody>
+          <a:bodyPr wrap="square" lIns="0" tIns="0" rIns="0" bIns="0" rtlCol="0" anchor="ctr"/>
+          <a:lstStyle/>
+          <a:p>
+            <a:pPr indent="0" marL="0">
+              <a:buNone/>
+            </a:pPr>
+            <a:r>
+              <a:rPr lang="en-US" sz="1300" b="1" dirty="0">
+                <a:solidFill>
+                  <a:srgbClr val="163341"/>
+                </a:solidFill>
+                <a:latin typeface="Calibri" pitchFamily="34" charset="0"/>
+                <a:ea typeface="Calibri" pitchFamily="34" charset="-122"/>
+                <a:cs typeface="Calibri" pitchFamily="34" charset="-120"/>
+              </a:rPr>
+              <a:t>Real-time delivery</a:t>
+            </a:r>
+            <a:endParaRPr lang="en-US" sz="1300" dirty="0"/>
+          </a:p>
+        </p:txBody>
+      </p:sp>
+      <p:sp>
+        <p:nvSpPr>
+          <p:cNvPr id="20" name="Text 18"/>
+          <p:cNvSpPr/>
+          <p:nvPr/>
+        </p:nvSpPr>
+        <p:spPr>
+          <a:xfrm>
+            <a:off x="4114800" y="3328416"/>
+            <a:ext cx="3429000" cy="566928"/>
+          </a:xfrm>
+          <a:prstGeom prst="rect">
+            <a:avLst/>
+          </a:prstGeom>
+          <a:noFill/>
+          <a:ln/>
+        </p:spPr>
+        <p:txBody>
+          <a:bodyPr wrap="square" lIns="0" tIns="0" rIns="0" bIns="0" rtlCol="0" anchor="ctr"/>
+          <a:lstStyle/>
+          <a:p>
+            <a:pPr indent="0" marL="0">
+              <a:buNone/>
+            </a:pPr>
+            <a:r>
+              <a:rPr lang="en-US" sz="1250" dirty="0">
+                <a:solidFill>
+                  <a:srgbClr val="5C6B73"/>
+                </a:solidFill>
+                <a:latin typeface="Calibri" pitchFamily="34" charset="0"/>
+                <a:ea typeface="Calibri" pitchFamily="34" charset="-122"/>
+                <a:cs typeface="Calibri" pitchFamily="34" charset="-120"/>
+              </a:rPr>
+              <a:t>Poll / channel subscriptions</a:t>
+            </a:r>
+            <a:endParaRPr lang="en-US" sz="1250" dirty="0"/>
+          </a:p>
+        </p:txBody>
+      </p:sp>
+      <p:sp>
+        <p:nvSpPr>
+          <p:cNvPr id="21" name="Text 19"/>
+          <p:cNvSpPr/>
+          <p:nvPr/>
+        </p:nvSpPr>
+        <p:spPr>
+          <a:xfrm>
+            <a:off x="7909560" y="3328416"/>
+            <a:ext cx="3502152" cy="566928"/>
+          </a:xfrm>
+          <a:prstGeom prst="rect">
+            <a:avLst/>
+          </a:prstGeom>
+          <a:noFill/>
+          <a:ln/>
+        </p:spPr>
+        <p:txBody>
+          <a:bodyPr wrap="square" lIns="0" tIns="0" rIns="0" bIns="0" rtlCol="0" anchor="ctr"/>
+          <a:lstStyle/>
+          <a:p>
+            <a:pPr indent="0" marL="0">
+              <a:buNone/>
+            </a:pPr>
+            <a:r>
+              <a:rPr lang="en-US" sz="1250" b="1" dirty="0">
+                <a:solidFill>
+                  <a:srgbClr val="9E241B"/>
+                </a:solidFill>
+                <a:latin typeface="Calibri" pitchFamily="34" charset="0"/>
+                <a:ea typeface="Calibri" pitchFamily="34" charset="-122"/>
+                <a:cs typeface="Calibri" pitchFamily="34" charset="-120"/>
+              </a:rPr>
+              <a:t>Native Pub/Sub &amp; Streams push</a:t>
+            </a:r>
+            <a:endParaRPr lang="en-US" sz="1250" dirty="0"/>
+          </a:p>
+        </p:txBody>
+      </p:sp>
+      <p:sp>
+        <p:nvSpPr>
+          <p:cNvPr id="22" name="Shape 20"/>
+          <p:cNvSpPr/>
+          <p:nvPr/>
+        </p:nvSpPr>
+        <p:spPr>
+          <a:xfrm>
+            <a:off x="7772400" y="3895344"/>
+            <a:ext cx="3776472" cy="566928"/>
+          </a:xfrm>
+          <a:prstGeom prst="rect">
+            <a:avLst/>
+          </a:prstGeom>
+          <a:solidFill>
+            <a:srgbClr val="FFF1F0"/>
+          </a:solidFill>
+          <a:ln/>
+        </p:spPr>
+      </p:sp>
+      <p:sp>
+        <p:nvSpPr>
+          <p:cNvPr id="23" name="Text 21"/>
+          <p:cNvSpPr/>
+          <p:nvPr/>
+        </p:nvSpPr>
+        <p:spPr>
+          <a:xfrm>
+            <a:off x="731520" y="3895344"/>
+            <a:ext cx="3063240" cy="566928"/>
+          </a:xfrm>
+          <a:prstGeom prst="rect">
+            <a:avLst/>
+          </a:prstGeom>
+          <a:noFill/>
+          <a:ln/>
+        </p:spPr>
+        <p:txBody>
+          <a:bodyPr wrap="square" lIns="0" tIns="0" rIns="0" bIns="0" rtlCol="0" anchor="ctr"/>
+          <a:lstStyle/>
+          <a:p>
+            <a:pPr indent="0" marL="0">
+              <a:buNone/>
+            </a:pPr>
+            <a:r>
+              <a:rPr lang="en-US" sz="1300" b="1" dirty="0">
+                <a:solidFill>
+                  <a:srgbClr val="163341"/>
+                </a:solidFill>
+                <a:latin typeface="Calibri" pitchFamily="34" charset="0"/>
+                <a:ea typeface="Calibri" pitchFamily="34" charset="-122"/>
+                <a:cs typeface="Calibri" pitchFamily="34" charset="-120"/>
+              </a:rPr>
+              <a:t>Data models</a:t>
+            </a:r>
+            <a:endParaRPr lang="en-US" sz="1300" dirty="0"/>
+          </a:p>
+        </p:txBody>
+      </p:sp>
+      <p:sp>
+        <p:nvSpPr>
+          <p:cNvPr id="24" name="Text 22"/>
+          <p:cNvSpPr/>
+          <p:nvPr/>
+        </p:nvSpPr>
+        <p:spPr>
+          <a:xfrm>
+            <a:off x="4114800" y="3895344"/>
+            <a:ext cx="3429000" cy="566928"/>
+          </a:xfrm>
+          <a:prstGeom prst="rect">
+            <a:avLst/>
+          </a:prstGeom>
+          <a:noFill/>
+          <a:ln/>
+        </p:spPr>
+        <p:txBody>
+          <a:bodyPr wrap="square" lIns="0" tIns="0" rIns="0" bIns="0" rtlCol="0" anchor="ctr"/>
+          <a:lstStyle/>
+          <a:p>
+            <a:pPr indent="0" marL="0">
+              <a:buNone/>
+            </a:pPr>
+            <a:r>
+              <a:rPr lang="en-US" sz="1250" dirty="0">
+                <a:solidFill>
+                  <a:srgbClr val="5C6B73"/>
+                </a:solidFill>
+                <a:latin typeface="Calibri" pitchFamily="34" charset="0"/>
+                <a:ea typeface="Calibri" pitchFamily="34" charset="-122"/>
+                <a:cs typeface="Calibri" pitchFamily="34" charset="-120"/>
+              </a:rPr>
+              <a:t>Time-series (OT-specific)</a:t>
+            </a:r>
+            <a:endParaRPr lang="en-US" sz="1250" dirty="0"/>
+          </a:p>
+        </p:txBody>
+      </p:sp>
+      <p:sp>
+        <p:nvSpPr>
+          <p:cNvPr id="25" name="Text 23"/>
+          <p:cNvSpPr/>
+          <p:nvPr/>
+        </p:nvSpPr>
+        <p:spPr>
+          <a:xfrm>
+            <a:off x="7909560" y="3895344"/>
+            <a:ext cx="3502152" cy="566928"/>
+          </a:xfrm>
+          <a:prstGeom prst="rect">
+            <a:avLst/>
+          </a:prstGeom>
+          <a:noFill/>
+          <a:ln/>
+        </p:spPr>
+        <p:txBody>
+          <a:bodyPr wrap="square" lIns="0" tIns="0" rIns="0" bIns="0" rtlCol="0" anchor="ctr"/>
+          <a:lstStyle/>
+          <a:p>
+            <a:pPr indent="0" marL="0">
+              <a:buNone/>
+            </a:pPr>
+            <a:r>
+              <a:rPr lang="en-US" sz="1250" b="1" dirty="0">
+                <a:solidFill>
+                  <a:srgbClr val="9E241B"/>
+                </a:solidFill>
+                <a:latin typeface="Calibri" pitchFamily="34" charset="0"/>
+                <a:ea typeface="Calibri" pitchFamily="34" charset="-122"/>
+                <a:cs typeface="Calibri" pitchFamily="34" charset="-120"/>
+              </a:rPr>
+              <a:t>TimeSeries + JSON + Search + Vector</a:t>
+            </a:r>
+            <a:endParaRPr lang="en-US" sz="1250" dirty="0"/>
+          </a:p>
+        </p:txBody>
+      </p:sp>
+      <p:sp>
+        <p:nvSpPr>
+          <p:cNvPr id="26" name="Shape 24"/>
+          <p:cNvSpPr/>
+          <p:nvPr/>
+        </p:nvSpPr>
+        <p:spPr>
+          <a:xfrm>
+            <a:off x="640080" y="4462272"/>
+            <a:ext cx="10908792" cy="566928"/>
+          </a:xfrm>
+          <a:prstGeom prst="rect">
+            <a:avLst/>
+          </a:prstGeom>
+          <a:solidFill>
+            <a:srgbClr val="EEF2F4"/>
+          </a:solidFill>
+          <a:ln/>
+        </p:spPr>
+      </p:sp>
+      <p:sp>
+        <p:nvSpPr>
+          <p:cNvPr id="27" name="Shape 25"/>
+          <p:cNvSpPr/>
+          <p:nvPr/>
+        </p:nvSpPr>
+        <p:spPr>
+          <a:xfrm>
+            <a:off x="7772400" y="4462272"/>
+            <a:ext cx="3776472" cy="566928"/>
+          </a:xfrm>
+          <a:prstGeom prst="rect">
+            <a:avLst/>
+          </a:prstGeom>
+          <a:solidFill>
+            <a:srgbClr val="FFF1F0"/>
+          </a:solidFill>
+          <a:ln/>
+        </p:spPr>
+      </p:sp>
+      <p:sp>
+        <p:nvSpPr>
+          <p:cNvPr id="28" name="Text 26"/>
+          <p:cNvSpPr/>
+          <p:nvPr/>
+        </p:nvSpPr>
+        <p:spPr>
+          <a:xfrm>
+            <a:off x="731520" y="4462272"/>
+            <a:ext cx="3063240" cy="566928"/>
+          </a:xfrm>
+          <a:prstGeom prst="rect">
+            <a:avLst/>
+          </a:prstGeom>
+          <a:noFill/>
+          <a:ln/>
+        </p:spPr>
+        <p:txBody>
+          <a:bodyPr wrap="square" lIns="0" tIns="0" rIns="0" bIns="0" rtlCol="0" anchor="ctr"/>
+          <a:lstStyle/>
+          <a:p>
+            <a:pPr indent="0" marL="0">
+              <a:buNone/>
+            </a:pPr>
+            <a:r>
+              <a:rPr lang="en-US" sz="1300" b="1" dirty="0">
+                <a:solidFill>
+                  <a:srgbClr val="163341"/>
+                </a:solidFill>
+                <a:latin typeface="Calibri" pitchFamily="34" charset="0"/>
+                <a:ea typeface="Calibri" pitchFamily="34" charset="-122"/>
+                <a:cs typeface="Calibri" pitchFamily="34" charset="-120"/>
+              </a:rPr>
+              <a:t>Load on OT systems</a:t>
+            </a:r>
+            <a:endParaRPr lang="en-US" sz="1300" dirty="0"/>
+          </a:p>
+        </p:txBody>
+      </p:sp>
+      <p:sp>
+        <p:nvSpPr>
+          <p:cNvPr id="29" name="Text 27"/>
+          <p:cNvSpPr/>
+          <p:nvPr/>
+        </p:nvSpPr>
+        <p:spPr>
+          <a:xfrm>
+            <a:off x="4114800" y="4462272"/>
+            <a:ext cx="3429000" cy="566928"/>
+          </a:xfrm>
+          <a:prstGeom prst="rect">
+            <a:avLst/>
+          </a:prstGeom>
+          <a:noFill/>
+          <a:ln/>
+        </p:spPr>
+        <p:txBody>
+          <a:bodyPr wrap="square" lIns="0" tIns="0" rIns="0" bIns="0" rtlCol="0" anchor="ctr"/>
+          <a:lstStyle/>
+          <a:p>
+            <a:pPr indent="0" marL="0">
+              <a:buNone/>
+            </a:pPr>
+            <a:r>
+              <a:rPr lang="en-US" sz="1250" dirty="0">
+                <a:solidFill>
+                  <a:srgbClr val="5C6B73"/>
+                </a:solidFill>
+                <a:latin typeface="Calibri" pitchFamily="34" charset="0"/>
+                <a:ea typeface="Calibri" pitchFamily="34" charset="-122"/>
+                <a:cs typeface="Calibri" pitchFamily="34" charset="-120"/>
+              </a:rPr>
+              <a:t>Every query taxes the historian</a:t>
+            </a:r>
+            <a:endParaRPr lang="en-US" sz="1250" dirty="0"/>
+          </a:p>
+        </p:txBody>
+      </p:sp>
+      <p:sp>
+        <p:nvSpPr>
+          <p:cNvPr id="30" name="Text 28"/>
+          <p:cNvSpPr/>
+          <p:nvPr/>
+        </p:nvSpPr>
+        <p:spPr>
+          <a:xfrm>
+            <a:off x="7909560" y="4462272"/>
+            <a:ext cx="3502152" cy="566928"/>
+          </a:xfrm>
+          <a:prstGeom prst="rect">
+            <a:avLst/>
+          </a:prstGeom>
+          <a:noFill/>
+          <a:ln/>
+        </p:spPr>
+        <p:txBody>
+          <a:bodyPr wrap="square" lIns="0" tIns="0" rIns="0" bIns="0" rtlCol="0" anchor="ctr"/>
+          <a:lstStyle/>
+          <a:p>
+            <a:pPr indent="0" marL="0">
+              <a:buNone/>
+            </a:pPr>
+            <a:r>
+              <a:rPr lang="en-US" sz="1250" b="1" dirty="0">
+                <a:solidFill>
+                  <a:srgbClr val="9E241B"/>
+                </a:solidFill>
+                <a:latin typeface="Calibri" pitchFamily="34" charset="0"/>
+                <a:ea typeface="Calibri" pitchFamily="34" charset="-122"/>
+                <a:cs typeface="Calibri" pitchFamily="34" charset="-120"/>
+              </a:rPr>
+              <a:t>Apps hit Redis; PI stays protected</a:t>
+            </a:r>
+            <a:endParaRPr lang="en-US" sz="1250" dirty="0"/>
+          </a:p>
+        </p:txBody>
+      </p:sp>
+      <p:sp>
+        <p:nvSpPr>
+          <p:cNvPr id="31" name="Shape 29"/>
+          <p:cNvSpPr/>
+          <p:nvPr/>
+        </p:nvSpPr>
+        <p:spPr>
+          <a:xfrm>
+            <a:off x="7772400" y="5029200"/>
+            <a:ext cx="3776472" cy="566928"/>
+          </a:xfrm>
+          <a:prstGeom prst="rect">
+            <a:avLst/>
+          </a:prstGeom>
+          <a:solidFill>
+            <a:srgbClr val="FFF1F0"/>
+          </a:solidFill>
+          <a:ln/>
+        </p:spPr>
+      </p:sp>
+      <p:sp>
+        <p:nvSpPr>
+          <p:cNvPr id="32" name="Text 30"/>
+          <p:cNvSpPr/>
+          <p:nvPr/>
+        </p:nvSpPr>
+        <p:spPr>
+          <a:xfrm>
+            <a:off x="731520" y="5029200"/>
+            <a:ext cx="3063240" cy="566928"/>
+          </a:xfrm>
+          <a:prstGeom prst="rect">
+            <a:avLst/>
+          </a:prstGeom>
+          <a:noFill/>
+          <a:ln/>
+        </p:spPr>
+        <p:txBody>
+          <a:bodyPr wrap="square" lIns="0" tIns="0" rIns="0" bIns="0" rtlCol="0" anchor="ctr"/>
+          <a:lstStyle/>
+          <a:p>
+            <a:pPr indent="0" marL="0">
+              <a:buNone/>
+            </a:pPr>
+            <a:r>
+              <a:rPr lang="en-US" sz="1300" b="1" dirty="0">
+                <a:solidFill>
+                  <a:srgbClr val="163341"/>
+                </a:solidFill>
+                <a:latin typeface="Calibri" pitchFamily="34" charset="0"/>
+                <a:ea typeface="Calibri" pitchFamily="34" charset="-122"/>
+                <a:cs typeface="Calibri" pitchFamily="34" charset="-120"/>
+              </a:rPr>
+              <a:t>Scaling &amp; deployment</a:t>
+            </a:r>
+            <a:endParaRPr lang="en-US" sz="1300" dirty="0"/>
+          </a:p>
+        </p:txBody>
+      </p:sp>
+      <p:sp>
+        <p:nvSpPr>
+          <p:cNvPr id="33" name="Text 31"/>
+          <p:cNvSpPr/>
+          <p:nvPr/>
+        </p:nvSpPr>
+        <p:spPr>
+          <a:xfrm>
+            <a:off x="4114800" y="5029200"/>
+            <a:ext cx="3429000" cy="566928"/>
+          </a:xfrm>
+          <a:prstGeom prst="rect">
+            <a:avLst/>
+          </a:prstGeom>
+          <a:noFill/>
+          <a:ln/>
+        </p:spPr>
+        <p:txBody>
+          <a:bodyPr wrap="square" lIns="0" tIns="0" rIns="0" bIns="0" rtlCol="0" anchor="ctr"/>
+          <a:lstStyle/>
+          <a:p>
+            <a:pPr indent="0" marL="0">
+              <a:buNone/>
+            </a:pPr>
+            <a:r>
+              <a:rPr lang="en-US" sz="1250" dirty="0">
+                <a:solidFill>
+                  <a:srgbClr val="5C6B73"/>
+                </a:solidFill>
+                <a:latin typeface="Calibri" pitchFamily="34" charset="0"/>
+                <a:ea typeface="Calibri" pitchFamily="34" charset="-122"/>
+                <a:cs typeface="Calibri" pitchFamily="34" charset="-120"/>
+              </a:rPr>
+              <a:t>Vertical; OT-licensed</a:t>
+            </a:r>
+            <a:endParaRPr lang="en-US" sz="1250" dirty="0"/>
+          </a:p>
+        </p:txBody>
+      </p:sp>
+      <p:sp>
+        <p:nvSpPr>
+          <p:cNvPr id="34" name="Text 32"/>
+          <p:cNvSpPr/>
+          <p:nvPr/>
+        </p:nvSpPr>
+        <p:spPr>
+          <a:xfrm>
+            <a:off x="7909560" y="5029200"/>
+            <a:ext cx="3502152" cy="566928"/>
+          </a:xfrm>
+          <a:prstGeom prst="rect">
+            <a:avLst/>
+          </a:prstGeom>
+          <a:noFill/>
+          <a:ln/>
+        </p:spPr>
+        <p:txBody>
+          <a:bodyPr wrap="square" lIns="0" tIns="0" rIns="0" bIns="0" rtlCol="0" anchor="ctr"/>
+          <a:lstStyle/>
+          <a:p>
+            <a:pPr indent="0" marL="0">
+              <a:buNone/>
+            </a:pPr>
+            <a:r>
+              <a:rPr lang="en-US" sz="1250" b="1" dirty="0">
+                <a:solidFill>
+                  <a:srgbClr val="9E241B"/>
+                </a:solidFill>
+                <a:latin typeface="Calibri" pitchFamily="34" charset="0"/>
+                <a:ea typeface="Calibri" pitchFamily="34" charset="-122"/>
+                <a:cs typeface="Calibri" pitchFamily="34" charset="-120"/>
+              </a:rPr>
+              <a:t>Horizontal, cloud-native, managed</a:t>
+            </a:r>
+            <a:endParaRPr lang="en-US" sz="1250" dirty="0"/>
+          </a:p>
+        </p:txBody>
+      </p:sp>
+      <p:sp>
+        <p:nvSpPr>
+          <p:cNvPr id="35" name="Shape 33"/>
+          <p:cNvSpPr/>
+          <p:nvPr/>
+        </p:nvSpPr>
+        <p:spPr>
+          <a:xfrm>
+            <a:off x="640080" y="5760720"/>
+            <a:ext cx="10908792" cy="603504"/>
+          </a:xfrm>
+          <a:prstGeom prst="roundRect">
+            <a:avLst>
+              <a:gd name="adj" fmla="val 12121"/>
+            </a:avLst>
+          </a:prstGeom>
+          <a:solidFill>
+            <a:srgbClr val="091A23"/>
+          </a:solidFill>
+          <a:ln/>
+        </p:spPr>
+      </p:sp>
+      <p:sp>
+        <p:nvSpPr>
+          <p:cNvPr id="36" name="Text 34"/>
+          <p:cNvSpPr/>
+          <p:nvPr/>
+        </p:nvSpPr>
+        <p:spPr>
+          <a:xfrm>
+            <a:off x="868680" y="5760720"/>
+            <a:ext cx="10424160" cy="603504"/>
+          </a:xfrm>
+          <a:prstGeom prst="rect">
+            <a:avLst/>
+          </a:prstGeom>
+          <a:noFill/>
+          <a:ln/>
+        </p:spPr>
+        <p:txBody>
+          <a:bodyPr wrap="square" lIns="0" tIns="0" rIns="0" bIns="0" rtlCol="0" anchor="ctr"/>
+          <a:lstStyle/>
+          <a:p>
+            <a:pPr indent="0" marL="0">
+              <a:lnSpc>
+                <a:spcPts val="1400"/>
+              </a:lnSpc>
+              <a:buNone/>
+            </a:pPr>
+            <a:r>
+              <a:rPr lang="en-US" sz="1200" b="1" dirty="0">
+                <a:solidFill>
+                  <a:srgbClr val="FFFFFF"/>
+                </a:solidFill>
+                <a:latin typeface="Calibri" pitchFamily="34" charset="0"/>
+                <a:ea typeface="Calibri" pitchFamily="34" charset="-122"/>
+                <a:cs typeface="Calibri" pitchFamily="34" charset="-120"/>
+              </a:rPr>
+              <a:t>Complementary, not a replacement:  </a:t>
+            </a:r>
+            <a:pPr indent="0" marL="0">
+              <a:lnSpc>
+                <a:spcPts val="1400"/>
+              </a:lnSpc>
+              <a:buNone/>
+            </a:pPr>
+            <a:r>
+              <a:rPr lang="en-US" sz="1200" dirty="0">
+                <a:solidFill>
+                  <a:srgbClr val="C6D2D7"/>
+                </a:solidFill>
+                <a:latin typeface="Calibri" pitchFamily="34" charset="0"/>
+                <a:ea typeface="Calibri" pitchFamily="34" charset="-122"/>
+                <a:cs typeface="Calibri" pitchFamily="34" charset="-120"/>
+              </a:rPr>
+              <a:t>PI remains the system of record and long-term historian; Redis is the low-latency serving and real-time layer in front of it.</a:t>
+            </a:r>
+            <a:endParaRPr lang="en-US" sz="1200" dirty="0"/>
+          </a:p>
+        </p:txBody>
+      </p:sp>
+      <p:sp>
+        <p:nvSpPr>
+          <p:cNvPr id="37" name="Text 35"/>
+          <p:cNvSpPr/>
+          <p:nvPr/>
+        </p:nvSpPr>
+        <p:spPr>
+          <a:xfrm>
+            <a:off x="502920" y="6473952"/>
+            <a:ext cx="7315200" cy="274320"/>
+          </a:xfrm>
+          <a:prstGeom prst="rect">
+            <a:avLst/>
+          </a:prstGeom>
+          <a:noFill/>
+          <a:ln/>
+        </p:spPr>
+        <p:txBody>
+          <a:bodyPr wrap="square" lIns="0" tIns="0" rIns="0" bIns="0" rtlCol="0" anchor="ctr"/>
+          <a:lstStyle/>
+          <a:p>
+            <a:pPr indent="0" marL="0">
+              <a:buNone/>
+            </a:pPr>
+            <a:r>
+              <a:rPr lang="en-US" sz="900" dirty="0">
+                <a:solidFill>
+                  <a:srgbClr val="5C6B73"/>
+                </a:solidFill>
+                <a:latin typeface="Calibri" pitchFamily="34" charset="0"/>
+                <a:ea typeface="Calibri" pitchFamily="34" charset="-122"/>
+                <a:cs typeface="Calibri" pitchFamily="34" charset="-120"/>
+              </a:rPr>
+              <a:t>github.com/amitmknit/aveva-pi-redis-integration</a:t>
+            </a:r>
+            <a:endParaRPr lang="en-US" sz="900" dirty="0"/>
+          </a:p>
+        </p:txBody>
+      </p:sp>
+      <p:sp>
+        <p:nvSpPr>
+          <p:cNvPr id="38" name="Text 36"/>
+          <p:cNvSpPr/>
+          <p:nvPr/>
+        </p:nvSpPr>
+        <p:spPr>
+          <a:xfrm>
+            <a:off x="8028432" y="6473952"/>
+            <a:ext cx="3657600" cy="274320"/>
+          </a:xfrm>
+          <a:prstGeom prst="rect">
+            <a:avLst/>
+          </a:prstGeom>
+          <a:noFill/>
+          <a:ln/>
+        </p:spPr>
+        <p:txBody>
+          <a:bodyPr wrap="square" lIns="0" tIns="0" rIns="0" bIns="0" rtlCol="0" anchor="ctr"/>
+          <a:lstStyle/>
+          <a:p>
+            <a:pPr algn="r" indent="0" marL="0">
+              <a:buNone/>
+            </a:pPr>
+            <a:r>
+              <a:rPr lang="en-US" sz="900" dirty="0">
+                <a:solidFill>
+                  <a:srgbClr val="5C6B73"/>
+                </a:solidFill>
+                <a:latin typeface="Calibri" pitchFamily="34" charset="0"/>
+                <a:ea typeface="Calibri" pitchFamily="34" charset="-122"/>
+                <a:cs typeface="Calibri" pitchFamily="34" charset="-120"/>
+              </a:rPr>
+              <a:t>Redis  ·  Proof of Concept</a:t>
+            </a:r>
+            <a:endParaRPr lang="en-US" sz="900" dirty="0"/>
+          </a:p>
+        </p:txBody>
+      </p:sp>
+    </p:spTree>
+  </p:cSld>
+  <p:clrMapOvr>
+    <a:masterClrMapping/>
+  </p:clrMapOvr>
+</p:sld>
+</file>
+
+<file path=ppt/slides/slide8.xml><?xml version="1.0" encoding="utf-8"?>
+<p:sld xmlns:a="http://schemas.openxmlformats.org/drawingml/2006/main" xmlns:r="http://schemas.openxmlformats.org/officeDocument/2006/relationships" xmlns:p="http://schemas.openxmlformats.org/presentationml/2006/main">
+  <p:cSld name="Slide 8">
+    <p:bg>
+      <p:bgPr>
+        <a:solidFill>
+          <a:srgbClr val="F6F8F9"/>
+        </a:solidFill>
+      </p:bgPr>
+    </p:bg>
+    <p:spTree>
+      <p:nvGrpSpPr>
+        <p:cNvPr id="1" name=""/>
+        <p:cNvGrpSpPr/>
+        <p:nvPr/>
+      </p:nvGrpSpPr>
+      <p:grpSpPr>
+        <a:xfrm>
+          <a:off x="0" y="0"/>
+          <a:ext cx="0" cy="0"/>
+          <a:chOff x="0" y="0"/>
+          <a:chExt cx="0" cy="0"/>
+        </a:xfrm>
+      </p:grpSpPr>
+      <p:sp>
+        <p:nvSpPr>
+          <p:cNvPr id="2" name="Text 0"/>
+          <p:cNvSpPr/>
+          <p:nvPr/>
+        </p:nvSpPr>
+        <p:spPr>
+          <a:xfrm>
             <a:off x="640080" y="502920"/>
-            <a:ext cx="5486400" cy="274320"/>
+            <a:ext cx="7315200" cy="274320"/>
           </a:xfrm>
           <a:prstGeom prst="rect">
             <a:avLst/>
@@ -7716,9 +9078,9 @@
 </p:sld>
 </file>
 
-<file path=ppt/slides/slide8.xml><?xml version="1.0" encoding="utf-8"?>
+<file path=ppt/slides/slide9.xml><?xml version="1.0" encoding="utf-8"?>
 <p:sld xmlns:a="http://schemas.openxmlformats.org/drawingml/2006/main" xmlns:r="http://schemas.openxmlformats.org/officeDocument/2006/relationships" xmlns:p="http://schemas.openxmlformats.org/presentationml/2006/main">
-  <p:cSld name="Slide 8">
+  <p:cSld name="Slide 9">
     <p:bg>
       <p:bgPr>
         <a:solidFill>

</xml_diff>